<commit_message>
Update PowerPoint for song #261 in FUBC - Українські
</commit_message>
<xml_diff>
--- a/fubc-ua/261-Мій Боже, я Твоє дитя (Пісні Спасенних №260).pptx
+++ b/fubc-ua/261-Мій Боже, я Твоє дитя (Пісні Спасенних №260).pptx
@@ -1607,7 +1607,7 @@
         </p:nvSpPr>
         <p:spPr>
           <a:xfrm>
-            <a:off x="1948764" y="3547872"/>
+            <a:off x="2047824" y="3547872"/>
             <a:ext cx="0" cy="1386840"/>
           </a:xfrm>
           <a:prstGeom prst="line">
@@ -1630,7 +1630,7 @@
         </p:nvSpPr>
         <p:spPr>
           <a:xfrm>
-            <a:off x="10249332" y="3547872"/>
+            <a:off x="10150272" y="3547872"/>
             <a:ext cx="0" cy="1386840"/>
           </a:xfrm>
           <a:prstGeom prst="line">
@@ -1653,8 +1653,8 @@
         </p:nvSpPr>
         <p:spPr>
           <a:xfrm>
-            <a:off x="10381412" y="4010152"/>
-            <a:ext cx="792480" cy="462280"/>
+            <a:off x="10249332" y="3921252"/>
+            <a:ext cx="1097280" cy="640080"/>
           </a:xfrm>
           <a:prstGeom prst="rect">
             <a:avLst/>
@@ -1670,9 +1670,9 @@
               <a:buNone/>
             </a:pPr>
             <a:r>
-              <a:rPr lang="en-US" sz="2600" b="1" dirty="0">
+              <a:rPr lang="en-US" sz="3600" b="1" dirty="0">
                 <a:solidFill>
-                  <a:srgbClr val="8A8A8A"/>
+                  <a:srgbClr val="BBBBBB"/>
                 </a:solidFill>
                 <a:latin typeface="Arial" pitchFamily="34" charset="0"/>
                 <a:ea typeface="Arial" pitchFamily="34" charset="-122"/>
@@ -1680,7 +1680,7 @@
               </a:rPr>
               <a:t>×2</a:t>
             </a:r>
-            <a:endParaRPr lang="en-US" sz="2600" dirty="0"/>
+            <a:endParaRPr lang="en-US" sz="3600" dirty="0"/>
           </a:p>
         </p:txBody>
       </p:sp>
@@ -1826,7 +1826,7 @@
         </p:nvSpPr>
         <p:spPr>
           <a:xfrm>
-            <a:off x="1927301" y="3547872"/>
+            <a:off x="2026361" y="3547872"/>
             <a:ext cx="0" cy="1386840"/>
           </a:xfrm>
           <a:prstGeom prst="line">
@@ -1849,7 +1849,7 @@
         </p:nvSpPr>
         <p:spPr>
           <a:xfrm>
-            <a:off x="10270795" y="3547872"/>
+            <a:off x="10171735" y="3547872"/>
             <a:ext cx="0" cy="1386840"/>
           </a:xfrm>
           <a:prstGeom prst="line">
@@ -1872,8 +1872,8 @@
         </p:nvSpPr>
         <p:spPr>
           <a:xfrm>
-            <a:off x="10402875" y="4010152"/>
-            <a:ext cx="792480" cy="462280"/>
+            <a:off x="10270795" y="3921252"/>
+            <a:ext cx="1097280" cy="640080"/>
           </a:xfrm>
           <a:prstGeom prst="rect">
             <a:avLst/>
@@ -1889,9 +1889,9 @@
               <a:buNone/>
             </a:pPr>
             <a:r>
-              <a:rPr lang="en-US" sz="2600" b="1" dirty="0">
+              <a:rPr lang="en-US" sz="3600" b="1" dirty="0">
                 <a:solidFill>
-                  <a:srgbClr val="8A8A8A"/>
+                  <a:srgbClr val="BBBBBB"/>
                 </a:solidFill>
                 <a:latin typeface="Arial" pitchFamily="34" charset="0"/>
                 <a:ea typeface="Arial" pitchFamily="34" charset="-122"/>
@@ -1899,7 +1899,7 @@
               </a:rPr>
               <a:t>×2</a:t>
             </a:r>
-            <a:endParaRPr lang="en-US" sz="2600" dirty="0"/>
+            <a:endParaRPr lang="en-US" sz="3600" dirty="0"/>
           </a:p>
         </p:txBody>
       </p:sp>
@@ -2045,7 +2045,7 @@
         </p:nvSpPr>
         <p:spPr>
           <a:xfrm>
-            <a:off x="1451483" y="3547872"/>
+            <a:off x="1550543" y="3547872"/>
             <a:ext cx="0" cy="1386840"/>
           </a:xfrm>
           <a:prstGeom prst="line">
@@ -2068,7 +2068,7 @@
         </p:nvSpPr>
         <p:spPr>
           <a:xfrm>
-            <a:off x="10746613" y="3547872"/>
+            <a:off x="10647553" y="3547872"/>
             <a:ext cx="0" cy="1386840"/>
           </a:xfrm>
           <a:prstGeom prst="line">
@@ -2091,8 +2091,8 @@
         </p:nvSpPr>
         <p:spPr>
           <a:xfrm>
-            <a:off x="10878693" y="4010152"/>
-            <a:ext cx="792480" cy="462280"/>
+            <a:off x="10746613" y="3921252"/>
+            <a:ext cx="1097280" cy="640080"/>
           </a:xfrm>
           <a:prstGeom prst="rect">
             <a:avLst/>
@@ -2108,9 +2108,9 @@
               <a:buNone/>
             </a:pPr>
             <a:r>
-              <a:rPr lang="en-US" sz="2600" b="1" dirty="0">
+              <a:rPr lang="en-US" sz="3600" b="1" dirty="0">
                 <a:solidFill>
-                  <a:srgbClr val="8A8A8A"/>
+                  <a:srgbClr val="BBBBBB"/>
                 </a:solidFill>
                 <a:latin typeface="Arial" pitchFamily="34" charset="0"/>
                 <a:ea typeface="Arial" pitchFamily="34" charset="-122"/>
@@ -2118,7 +2118,7 @@
               </a:rPr>
               <a:t>×2</a:t>
             </a:r>
-            <a:endParaRPr lang="en-US" sz="2600" dirty="0"/>
+            <a:endParaRPr lang="en-US" sz="3600" dirty="0"/>
           </a:p>
         </p:txBody>
       </p:sp>
@@ -2264,7 +2264,7 @@
         </p:nvSpPr>
         <p:spPr>
           <a:xfrm>
-            <a:off x="1426718" y="3547872"/>
+            <a:off x="1525778" y="3547872"/>
             <a:ext cx="0" cy="1386840"/>
           </a:xfrm>
           <a:prstGeom prst="line">
@@ -2287,7 +2287,7 @@
         </p:nvSpPr>
         <p:spPr>
           <a:xfrm>
-            <a:off x="10771378" y="3547872"/>
+            <a:off x="10672318" y="3547872"/>
             <a:ext cx="0" cy="1386840"/>
           </a:xfrm>
           <a:prstGeom prst="line">
@@ -2310,8 +2310,8 @@
         </p:nvSpPr>
         <p:spPr>
           <a:xfrm>
-            <a:off x="10903458" y="4010152"/>
-            <a:ext cx="792480" cy="462280"/>
+            <a:off x="10771378" y="3921252"/>
+            <a:ext cx="1097280" cy="640080"/>
           </a:xfrm>
           <a:prstGeom prst="rect">
             <a:avLst/>
@@ -2327,9 +2327,9 @@
               <a:buNone/>
             </a:pPr>
             <a:r>
-              <a:rPr lang="en-US" sz="2600" b="1" dirty="0">
+              <a:rPr lang="en-US" sz="3600" b="1" dirty="0">
                 <a:solidFill>
-                  <a:srgbClr val="8A8A8A"/>
+                  <a:srgbClr val="BBBBBB"/>
                 </a:solidFill>
                 <a:latin typeface="Arial" pitchFamily="34" charset="0"/>
                 <a:ea typeface="Arial" pitchFamily="34" charset="-122"/>
@@ -2337,7 +2337,7 @@
               </a:rPr>
               <a:t>×2</a:t>
             </a:r>
-            <a:endParaRPr lang="en-US" sz="2600" dirty="0"/>
+            <a:endParaRPr lang="en-US" sz="3600" dirty="0"/>
           </a:p>
         </p:txBody>
       </p:sp>
@@ -2396,12 +2396,12 @@
           <a:p>
             <a:pPr algn="ctr" indent="0" marL="0">
               <a:lnSpc>
-                <a:spcPts val="6100"/>
+                <a:spcPts val="6200"/>
               </a:lnSpc>
               <a:buNone/>
             </a:pPr>
             <a:r>
-              <a:rPr lang="en-US" sz="5100" b="1" dirty="0">
+              <a:rPr lang="en-US" sz="5200" b="1" dirty="0">
                 <a:solidFill>
                   <a:srgbClr val="FFFFFF"/>
                 </a:solidFill>
@@ -2411,17 +2411,17 @@
               </a:rPr>
               <a:t>Я радість хочу принести</a:t>
             </a:r>
-            <a:endParaRPr lang="en-US" sz="5100" dirty="0"/>
+            <a:endParaRPr lang="en-US" sz="5200" dirty="0"/>
           </a:p>
           <a:p>
             <a:pPr algn="ctr" indent="0" marL="0">
               <a:lnSpc>
-                <a:spcPts val="6100"/>
+                <a:spcPts val="6200"/>
               </a:lnSpc>
               <a:buNone/>
             </a:pPr>
             <a:r>
-              <a:rPr lang="en-US" sz="5100" b="1" dirty="0">
+              <a:rPr lang="en-US" sz="5200" b="1" dirty="0">
                 <a:solidFill>
                   <a:srgbClr val="FFFFFF"/>
                 </a:solidFill>
@@ -2431,17 +2431,17 @@
               </a:rPr>
               <a:t>Тобі життям своїм,</a:t>
             </a:r>
-            <a:endParaRPr lang="en-US" sz="5100" dirty="0"/>
+            <a:endParaRPr lang="en-US" sz="5200" dirty="0"/>
           </a:p>
           <a:p>
             <a:pPr algn="ctr" indent="0" marL="0">
               <a:lnSpc>
-                <a:spcPts val="6100"/>
+                <a:spcPts val="6200"/>
               </a:lnSpc>
               <a:buNone/>
             </a:pPr>
             <a:r>
-              <a:rPr lang="en-US" sz="5100" b="1" dirty="0">
+              <a:rPr lang="en-US" sz="5200" b="1" dirty="0">
                 <a:solidFill>
                   <a:srgbClr val="FFFFFF"/>
                 </a:solidFill>
@@ -2451,17 +2451,17 @@
               </a:rPr>
               <a:t>покірно йти шляхом вузьким</a:t>
             </a:r>
-            <a:endParaRPr lang="en-US" sz="5100" dirty="0"/>
+            <a:endParaRPr lang="en-US" sz="5200" dirty="0"/>
           </a:p>
           <a:p>
             <a:pPr algn="ctr" indent="0" marL="0">
               <a:lnSpc>
-                <a:spcPts val="6100"/>
+                <a:spcPts val="6200"/>
               </a:lnSpc>
               <a:buNone/>
             </a:pPr>
             <a:r>
-              <a:rPr lang="en-US" sz="5100" b="1" dirty="0">
+              <a:rPr lang="en-US" sz="5200" b="1" dirty="0">
                 <a:solidFill>
                   <a:srgbClr val="FFFFFF"/>
                 </a:solidFill>
@@ -2471,7 +2471,7 @@
               </a:rPr>
               <a:t>у небеса Твої.</a:t>
             </a:r>
-            <a:endParaRPr lang="en-US" sz="5100" dirty="0"/>
+            <a:endParaRPr lang="en-US" sz="5200" dirty="0"/>
           </a:p>
         </p:txBody>
       </p:sp>
@@ -2483,14 +2483,14 @@
         </p:nvSpPr>
         <p:spPr>
           <a:xfrm>
-            <a:off x="1089412" y="3545586"/>
-            <a:ext cx="0" cy="1360170"/>
+            <a:off x="1090244" y="3547872"/>
+            <a:ext cx="0" cy="1386840"/>
           </a:xfrm>
           <a:prstGeom prst="line">
             <a:avLst/>
           </a:prstGeom>
           <a:noFill/>
-          <a:ln w="24912">
+          <a:ln w="25400">
             <a:solidFill>
               <a:srgbClr val="8A8A8A"/>
             </a:solidFill>
@@ -2506,14 +2506,14 @@
         </p:nvSpPr>
         <p:spPr>
           <a:xfrm>
-            <a:off x="11108684" y="3545586"/>
-            <a:ext cx="0" cy="1360170"/>
+            <a:off x="11107852" y="3547872"/>
+            <a:ext cx="0" cy="1386840"/>
           </a:xfrm>
           <a:prstGeom prst="line">
             <a:avLst/>
           </a:prstGeom>
           <a:noFill/>
-          <a:ln w="24912">
+          <a:ln w="25400">
             <a:solidFill>
               <a:srgbClr val="8A8A8A"/>
             </a:solidFill>
@@ -2529,8 +2529,8 @@
         </p:nvSpPr>
         <p:spPr>
           <a:xfrm>
-            <a:off x="11238224" y="3994531"/>
-            <a:ext cx="792480" cy="462280"/>
+            <a:off x="11206912" y="3921252"/>
+            <a:ext cx="1097280" cy="640080"/>
           </a:xfrm>
           <a:prstGeom prst="rect">
             <a:avLst/>
@@ -2546,9 +2546,9 @@
               <a:buNone/>
             </a:pPr>
             <a:r>
-              <a:rPr lang="en-US" sz="2600" b="1" dirty="0">
+              <a:rPr lang="en-US" sz="3600" b="1" dirty="0">
                 <a:solidFill>
-                  <a:srgbClr val="8A8A8A"/>
+                  <a:srgbClr val="BBBBBB"/>
                 </a:solidFill>
                 <a:latin typeface="Arial" pitchFamily="34" charset="0"/>
                 <a:ea typeface="Arial" pitchFamily="34" charset="-122"/>
@@ -2556,7 +2556,7 @@
               </a:rPr>
               <a:t>×2</a:t>
             </a:r>
-            <a:endParaRPr lang="en-US" sz="2600" dirty="0"/>
+            <a:endParaRPr lang="en-US" sz="3600" dirty="0"/>
           </a:p>
         </p:txBody>
       </p:sp>

</xml_diff>